<commit_message>
Bind P0-07 financial charts to audited sources
</commit_message>
<xml_diff>
--- a/docs/product/ppt-benchmark-materials/PPT-P0-07/p0-07-reference.pptx
+++ b/docs/product/ppt-benchmark-materials/PPT-P0-07/p0-07-reference.pptx
@@ -148,7 +148,7 @@
           </c:spPr>
           <c:invertIfNegative val="0"/>
           <c:dLbls>
-            <c:numFmt formatCode="#,##0" sourceLinked="0"/>
+            <c:numFmt formatCode="#,##0.########" sourceLinked="0"/>
             <c:txPr>
               <a:bodyPr/>
               <a:lstStyle/>
@@ -156,9 +156,9 @@
                 <a:pPr>
                   <a:defRPr b="0" i="0" strike="noStrike" sz="1200" u="none">
                     <a:solidFill>
-                      <a:srgbClr val="000000"/>
+                      <a:srgbClr val="173248"/>
                     </a:solidFill>
-                    <a:latin typeface="Arial"/>
+                    <a:latin typeface="Noto Sans CJK SC"/>
                   </a:defRPr>
                 </a:pPr>
               </a:p>
@@ -204,7 +204,7 @@
           </c:val>
         </c:ser>
         <c:dLbls>
-          <c:numFmt formatCode="#,##0" sourceLinked="0"/>
+          <c:numFmt formatCode="#,##0.########" sourceLinked="0"/>
           <c:txPr>
             <a:bodyPr/>
             <a:lstStyle/>
@@ -212,9 +212,9 @@
               <a:pPr>
                 <a:defRPr b="0" i="0" strike="noStrike" sz="1200" u="none">
                   <a:solidFill>
-                    <a:srgbClr val="000000"/>
+                    <a:srgbClr val="173248"/>
                   </a:solidFill>
-                  <a:latin typeface="Arial"/>
+                  <a:latin typeface="Noto Sans CJK SC"/>
                 </a:defRPr>
               </a:pPr>
             </a:p>
@@ -247,7 +247,7 @@
         <c:spPr>
           <a:ln w="12700" cap="flat">
             <a:solidFill>
-              <a:srgbClr val="888888"/>
+              <a:srgbClr val="173248"/>
             </a:solidFill>
             <a:prstDash val="solid"/>
             <a:round/>
@@ -260,7 +260,7 @@
             <a:pPr>
               <a:defRPr sz="1200" b="0" i="0" u="none" strike="noStrike">
                 <a:solidFill>
-                  <a:srgbClr val="000000"/>
+                  <a:srgbClr val="173248"/>
                 </a:solidFill>
                 <a:latin typeface="Noto Sans CJK SC"/>
               </a:defRPr>
@@ -286,7 +286,7 @@
           <c:spPr>
             <a:ln w="12700" cap="flat">
               <a:solidFill>
-                <a:srgbClr val="888888"/>
+                <a:srgbClr val="173248"/>
               </a:solidFill>
               <a:prstDash val="solid"/>
               <a:round/>
@@ -300,7 +300,7 @@
         <c:spPr>
           <a:ln w="12700" cap="flat">
             <a:solidFill>
-              <a:srgbClr val="888888"/>
+              <a:srgbClr val="173248"/>
             </a:solidFill>
             <a:prstDash val="solid"/>
             <a:round/>
@@ -313,7 +313,7 @@
             <a:pPr>
               <a:defRPr sz="1200" b="0" i="0" u="none" strike="noStrike">
                 <a:solidFill>
-                  <a:srgbClr val="000000"/>
+                  <a:srgbClr val="173248"/>
                 </a:solidFill>
                 <a:latin typeface="Noto Sans CJK SC"/>
               </a:defRPr>
@@ -326,7 +326,9 @@
         <c:crossBetween val="between"/>
       </c:valAx>
       <c:spPr>
-        <a:noFill/>
+        <a:solidFill>
+          <a:srgbClr val="FFFFFF"/>
+        </a:solidFill>
         <a:ln>
           <a:noFill/>
         </a:ln>
@@ -337,7 +339,9 @@
     <c:dispBlanksAs val="span"/>
   </c:chart>
   <c:spPr>
-    <a:noFill/>
+    <a:solidFill>
+      <a:srgbClr val="FFFFFF"/>
+    </a:solidFill>
     <a:ln>
       <a:noFill/>
     </a:ln>
@@ -383,7 +387,7 @@
           </c:spPr>
           <c:invertIfNegative val="0"/>
           <c:dLbls>
-            <c:numFmt formatCode="#,##0" sourceLinked="0"/>
+            <c:numFmt formatCode="#,##0.########" sourceLinked="0"/>
             <c:txPr>
               <a:bodyPr/>
               <a:lstStyle/>
@@ -391,9 +395,9 @@
                 <a:pPr>
                   <a:defRPr b="0" i="0" strike="noStrike" sz="1200" u="none">
                     <a:solidFill>
-                      <a:srgbClr val="000000"/>
+                      <a:srgbClr val="173248"/>
                     </a:solidFill>
-                    <a:latin typeface="Arial"/>
+                    <a:latin typeface="Noto Sans CJK SC"/>
                   </a:defRPr>
                 </a:pPr>
               </a:p>
@@ -439,7 +443,7 @@
           </c:val>
         </c:ser>
         <c:dLbls>
-          <c:numFmt formatCode="#,##0" sourceLinked="0"/>
+          <c:numFmt formatCode="#,##0.########" sourceLinked="0"/>
           <c:txPr>
             <a:bodyPr/>
             <a:lstStyle/>
@@ -447,9 +451,9 @@
               <a:pPr>
                 <a:defRPr b="0" i="0" strike="noStrike" sz="1200" u="none">
                   <a:solidFill>
-                    <a:srgbClr val="000000"/>
+                    <a:srgbClr val="173248"/>
                   </a:solidFill>
-                  <a:latin typeface="Arial"/>
+                  <a:latin typeface="Noto Sans CJK SC"/>
                 </a:defRPr>
               </a:pPr>
             </a:p>
@@ -482,7 +486,7 @@
         <c:spPr>
           <a:ln w="12700" cap="flat">
             <a:solidFill>
-              <a:srgbClr val="888888"/>
+              <a:srgbClr val="173248"/>
             </a:solidFill>
             <a:prstDash val="solid"/>
             <a:round/>
@@ -495,7 +499,7 @@
             <a:pPr>
               <a:defRPr sz="1200" b="0" i="0" u="none" strike="noStrike">
                 <a:solidFill>
-                  <a:srgbClr val="000000"/>
+                  <a:srgbClr val="173248"/>
                 </a:solidFill>
                 <a:latin typeface="Noto Sans CJK SC"/>
               </a:defRPr>
@@ -521,7 +525,7 @@
           <c:spPr>
             <a:ln w="12700" cap="flat">
               <a:solidFill>
-                <a:srgbClr val="888888"/>
+                <a:srgbClr val="173248"/>
               </a:solidFill>
               <a:prstDash val="solid"/>
               <a:round/>
@@ -535,7 +539,7 @@
         <c:spPr>
           <a:ln w="12700" cap="flat">
             <a:solidFill>
-              <a:srgbClr val="888888"/>
+              <a:srgbClr val="173248"/>
             </a:solidFill>
             <a:prstDash val="solid"/>
             <a:round/>
@@ -548,7 +552,7 @@
             <a:pPr>
               <a:defRPr sz="1200" b="0" i="0" u="none" strike="noStrike">
                 <a:solidFill>
-                  <a:srgbClr val="000000"/>
+                  <a:srgbClr val="173248"/>
                 </a:solidFill>
                 <a:latin typeface="Noto Sans CJK SC"/>
               </a:defRPr>
@@ -561,7 +565,9 @@
         <c:crossBetween val="between"/>
       </c:valAx>
       <c:spPr>
-        <a:noFill/>
+        <a:solidFill>
+          <a:srgbClr val="FFFFFF"/>
+        </a:solidFill>
         <a:ln>
           <a:noFill/>
         </a:ln>
@@ -572,7 +578,9 @@
     <c:dispBlanksAs val="span"/>
   </c:chart>
   <c:spPr>
-    <a:noFill/>
+    <a:solidFill>
+      <a:srgbClr val="FFFFFF"/>
+    </a:solidFill>
     <a:ln>
       <a:noFill/>
     </a:ln>
@@ -618,7 +626,7 @@
           </c:spPr>
           <c:invertIfNegative val="0"/>
           <c:dLbls>
-            <c:numFmt formatCode="#,##0" sourceLinked="0"/>
+            <c:numFmt formatCode="#,##0.########" sourceLinked="0"/>
             <c:txPr>
               <a:bodyPr/>
               <a:lstStyle/>
@@ -626,9 +634,9 @@
                 <a:pPr>
                   <a:defRPr b="0" i="0" strike="noStrike" sz="1200" u="none">
                     <a:solidFill>
-                      <a:srgbClr val="000000"/>
+                      <a:srgbClr val="173248"/>
                     </a:solidFill>
-                    <a:latin typeface="Arial"/>
+                    <a:latin typeface="Noto Sans CJK SC"/>
                   </a:defRPr>
                 </a:pPr>
               </a:p>
@@ -674,7 +682,7 @@
           </c:val>
         </c:ser>
         <c:dLbls>
-          <c:numFmt formatCode="#,##0" sourceLinked="0"/>
+          <c:numFmt formatCode="#,##0.########" sourceLinked="0"/>
           <c:txPr>
             <a:bodyPr/>
             <a:lstStyle/>
@@ -682,9 +690,9 @@
               <a:pPr>
                 <a:defRPr b="0" i="0" strike="noStrike" sz="1200" u="none">
                   <a:solidFill>
-                    <a:srgbClr val="000000"/>
+                    <a:srgbClr val="173248"/>
                   </a:solidFill>
-                  <a:latin typeface="Arial"/>
+                  <a:latin typeface="Noto Sans CJK SC"/>
                 </a:defRPr>
               </a:pPr>
             </a:p>
@@ -717,7 +725,7 @@
         <c:spPr>
           <a:ln w="12700" cap="flat">
             <a:solidFill>
-              <a:srgbClr val="888888"/>
+              <a:srgbClr val="173248"/>
             </a:solidFill>
             <a:prstDash val="solid"/>
             <a:round/>
@@ -730,7 +738,7 @@
             <a:pPr>
               <a:defRPr sz="1200" b="0" i="0" u="none" strike="noStrike">
                 <a:solidFill>
-                  <a:srgbClr val="000000"/>
+                  <a:srgbClr val="173248"/>
                 </a:solidFill>
                 <a:latin typeface="Noto Sans CJK SC"/>
               </a:defRPr>
@@ -756,7 +764,7 @@
           <c:spPr>
             <a:ln w="12700" cap="flat">
               <a:solidFill>
-                <a:srgbClr val="888888"/>
+                <a:srgbClr val="173248"/>
               </a:solidFill>
               <a:prstDash val="solid"/>
               <a:round/>
@@ -770,7 +778,7 @@
         <c:spPr>
           <a:ln w="12700" cap="flat">
             <a:solidFill>
-              <a:srgbClr val="888888"/>
+              <a:srgbClr val="173248"/>
             </a:solidFill>
             <a:prstDash val="solid"/>
             <a:round/>
@@ -783,7 +791,7 @@
             <a:pPr>
               <a:defRPr sz="1200" b="0" i="0" u="none" strike="noStrike">
                 <a:solidFill>
-                  <a:srgbClr val="000000"/>
+                  <a:srgbClr val="173248"/>
                 </a:solidFill>
                 <a:latin typeface="Noto Sans CJK SC"/>
               </a:defRPr>
@@ -796,7 +804,9 @@
         <c:crossBetween val="between"/>
       </c:valAx>
       <c:spPr>
-        <a:noFill/>
+        <a:solidFill>
+          <a:srgbClr val="FFFFFF"/>
+        </a:solidFill>
         <a:ln>
           <a:noFill/>
         </a:ln>
@@ -807,7 +817,9 @@
     <c:dispBlanksAs val="span"/>
   </c:chart>
   <c:spPr>
-    <a:noFill/>
+    <a:solidFill>
+      <a:srgbClr val="FFFFFF"/>
+    </a:solidFill>
     <a:ln>
       <a:noFill/>
     </a:ln>
@@ -1216,6 +1228,12 @@
               <a:rPr lang="en-US" dirty="0"/>
               <a:t>2024 财年表现：期间与来源
 参考稿：年度审计数值与未经审计业绩披露分开；同比为独立计算。
+[basis] https://s2.q4cdn.com/470004039/files/doc_earnings/2024/q4/filing/10-Q4-2024-As-Filed.pdf ; local:data-dictionary.json · PDF 第 32 页／印刷第 29 页 ; asOf、currency、unit、basis
+2024 与 2023 财年结束日分别为 2024-09-28、2023-09-30；合并报表单位为百万美元。
+[audit] https://s2.q4cdn.com/470004039/files/doc_earnings/2024/q4/filing/10-Q4-2024-As-Filed.pdf · PDF 第 51 页／印刷第 48 页
+主要年度数值取自包含独立审计意见的 Apple FY2024 Form 10-K。
+[release-status] https://www.apple.com/newsroom/pdfs/fy2024-q4/FY24_Q4_Consolidated_Financial_Statements.pdf · PDF 第 1 页
+2024-10-31 官方 Q4 业绩表标为 Unaudited，仅用于交叉核对。
 Attribution supplied by the input; source accuracy and license rights have not been independently verified.</a:t>
             </a:r>
             <a:endParaRPr lang="en-US" dirty="0"/>
@@ -1306,6 +1324,12 @@
               <a:rPr lang="en-US" dirty="0"/>
               <a:t>目录与审计口径
 参考稿：年度审计数值与未经审计业绩披露分开；同比为独立计算。
+[basis] https://s2.q4cdn.com/470004039/files/doc_earnings/2024/q4/filing/10-Q4-2024-As-Filed.pdf ; local:data-dictionary.json · PDF 第 32 页／印刷第 29 页 ; asOf、currency、unit、basis
+2024 与 2023 财年结束日分别为 2024-09-28、2023-09-30；合并报表单位为百万美元。
+[audit] https://s2.q4cdn.com/470004039/files/doc_earnings/2024/q4/filing/10-Q4-2024-As-Filed.pdf · PDF 第 51 页／印刷第 48 页
+主要年度数值取自包含独立审计意见的 Apple FY2024 Form 10-K。
+[release-status] https://www.apple.com/newsroom/pdfs/fy2024-q4/FY24_Q4_Consolidated_Financial_Statements.pdf · PDF 第 1 页
+2024-10-31 官方 Q4 业绩表标为 Unaudited，仅用于交叉核对。
 Attribution supplied by the input; source accuracy and license rights have not been independently verified.</a:t>
             </a:r>
             <a:endParaRPr lang="en-US" dirty="0"/>
@@ -1396,8 +1420,12 @@
               <a:rPr lang="en-US" dirty="0"/>
               <a:t>收入：年度值与同比（百万美元）
 参考稿：年度审计数值与未经审计业绩披露分开；同比为独立计算。
-[net_sales] Apple Inc. FY2024 Form 10-K, audited consolidated statements · 印刷第 29 页
-净销售额：2024 391035，2023 383285，百万美元
+[net_sales-2023] https://s2.q4cdn.com/470004039/files/doc_earnings/2024/q4/filing/10-Q4-2024-As-Filed.pdf ; local:independent-recalc.csv · PDF 32 / 印 29 ; CSV net_sales FY2023
+净销售额 2023 财年为 383,285 百万美元。
+[net_sales-2024] https://s2.q4cdn.com/470004039/files/doc_earnings/2024/q4/filing/10-Q4-2024-As-Filed.pdf ; local:independent-recalc.csv · PDF 32 / 印 29 ; CSV net_sales FY2024
+净销售额 2024 财年为 391,035 百万美元。
+[net_sales-yoy] local:independent-recalc.csv · CSV net_sales 行
+净销售额 2024 相对 2023 财年同比 +2.02%，为本包独立复算。
 Attribution supplied by the input; source accuracy and license rights have not been independently verified.</a:t>
             </a:r>
             <a:endParaRPr lang="en-US" dirty="0"/>
@@ -1488,8 +1516,12 @@
               <a:rPr lang="en-US" dirty="0"/>
               <a:t>利润：年度值与同比（百万美元）
 参考稿：年度审计数值与未经审计业绩披露分开；同比为独立计算。
-[net_income] Apple Inc. FY2024 Form 10-K, audited consolidated statements · 印刷第 29 页
-净利润：2024 93736，2023 96995，百万美元
+[net_income-2023] https://s2.q4cdn.com/470004039/files/doc_earnings/2024/q4/filing/10-Q4-2024-As-Filed.pdf ; local:independent-recalc.csv · PDF 32 / 印 29 ; CSV net_income FY2023
+净利润 2023 财年为 96,995 百万美元。
+[net_income-2024] https://s2.q4cdn.com/470004039/files/doc_earnings/2024/q4/filing/10-Q4-2024-As-Filed.pdf ; local:independent-recalc.csv · PDF 32 / 印 29 ; CSV net_income FY2024
+净利润 2024 财年为 93,736 百万美元。
+[net_income-yoy] local:independent-recalc.csv · CSV net_income 行
+净利润 2024 相对 2023 财年同比 -3.36%，为本包独立复算。
 Attribution supplied by the input; source accuracy and license rights have not been independently verified.</a:t>
             </a:r>
             <a:endParaRPr lang="en-US" dirty="0"/>
@@ -1580,8 +1612,12 @@
               <a:rPr lang="en-US" dirty="0"/>
               <a:t>经营活动现金流：年度值与同比（百万美元）
 参考稿：年度审计数值与未经审计业绩披露分开；同比为独立计算。
-[operating_cash_flow] Apple Inc. FY2024 Form 10-K, audited consolidated statements · 印刷第 33 页
-经营活动现金流：2024 118254，2023 110543，百万美元
+[operating_cash_flow-2023] https://s2.q4cdn.com/470004039/files/doc_earnings/2024/q4/filing/10-Q4-2024-As-Filed.pdf ; local:independent-recalc.csv · PDF 36 / 印 33 ; CSV operating_cash_flow FY2023
+经营活动现金流 2023 财年为 110,543 百万美元。
+[operating_cash_flow-2024] https://s2.q4cdn.com/470004039/files/doc_earnings/2024/q4/filing/10-Q4-2024-As-Filed.pdf ; local:independent-recalc.csv · PDF 36 / 印 33 ; CSV operating_cash_flow FY2024
+经营活动现金流 2024 财年为 118,254 百万美元。
+[operating_cash_flow-yoy] local:independent-recalc.csv · CSV operating_cash_flow 行
+经营活动现金流 2024 相对 2023 财年同比 +6.98%，为本包独立复算。
 Attribution supplied by the input; source accuracy and license rights have not been independently verified.</a:t>
             </a:r>
             <a:endParaRPr lang="en-US" dirty="0"/>
@@ -1672,6 +1708,12 @@
               <a:rPr lang="en-US" dirty="0"/>
               <a:t>三指标可编辑图表与公式
 参考稿：年度审计数值与未经审计业绩披露分开；同比为独立计算。
+[net_sales-yoy] local:independent-recalc.csv · CSV net_sales 行
+净销售额 2024 相对 2023 财年同比 +2.02%，为本包独立复算。
+[net_income-yoy] local:independent-recalc.csv · CSV net_income 行
+净利润 2024 相对 2023 财年同比 -3.36%，为本包独立复算。
+[operating_cash_flow-yoy] local:independent-recalc.csv · CSV operating_cash_flow 行
+经营活动现金流 2024 相对 2023 财年同比 +6.98%，为本包独立复算。
 Attribution supplied by the input; source accuracy and license rights have not been independently verified.</a:t>
             </a:r>
             <a:endParaRPr lang="en-US" dirty="0"/>
@@ -1762,6 +1804,10 @@
               <a:rPr lang="en-US" dirty="0"/>
               <a:t>差异、限制与待审事项
 参考稿：年度审计数值与未经审计业绩披露分开；同比为独立计算。
+[net_income-yoy] local:independent-recalc.csv · CSV net_income 行
+净利润 2024 相对 2023 财年同比 -3.36%，为本包独立复算。
+[release-status] https://www.apple.com/newsroom/pdfs/fy2024-q4/FY24_Q4_Consolidated_Financial_Statements.pdf · PDF 第 1 页
+2024-10-31 官方 Q4 业绩表标为 Unaudited，仅用于交叉核对。
 Attribution supplied by the input; source accuracy and license rights have not been independently verified.</a:t>
             </a:r>
             <a:endParaRPr lang="en-US" dirty="0"/>
@@ -1852,6 +1898,12 @@
               <a:rPr lang="en-US" dirty="0"/>
               <a:t>总结与来源页码
 参考稿：年度审计数值与未经审计业绩披露分开；同比为独立计算。
+[basis] https://s2.q4cdn.com/470004039/files/doc_earnings/2024/q4/filing/10-Q4-2024-As-Filed.pdf ; local:data-dictionary.json · PDF 第 32 页／印刷第 29 页 ; asOf、currency、unit、basis
+2024 与 2023 财年结束日分别为 2024-09-28、2023-09-30；合并报表单位为百万美元。
+[audit] https://s2.q4cdn.com/470004039/files/doc_earnings/2024/q4/filing/10-Q4-2024-As-Filed.pdf · PDF 第 51 页／印刷第 48 页
+主要年度数值取自包含独立审计意见的 Apple FY2024 Form 10-K。
+[release-status] https://www.apple.com/newsroom/pdfs/fy2024-q4/FY24_Q4_Consolidated_Financial_Statements.pdf · PDF 第 1 页
+2024-10-31 官方 Q4 业绩表标为 Unaudited，仅用于交叉核对。
 Attribution supplied by the input; source accuracy and license rights have not been independently verified.</a:t>
             </a:r>
             <a:endParaRPr lang="en-US" dirty="0"/>
@@ -2311,7 +2363,7 @@
         </p:nvSpPr>
         <p:spPr>
           <a:xfrm>
-            <a:off x="822960" y="6355080"/>
+            <a:off x="822960" y="6053328"/>
             <a:ext cx="10424160" cy="228600"/>
           </a:xfrm>
           <a:prstGeom prst="rect">
@@ -2339,6 +2391,45 @@
               <a:t>来源：Apple FY2024 Form 10-K；待财务审阅</a:t>
             </a:r>
             <a:endParaRPr lang="en-US" sz="900" dirty="0"/>
+          </a:p>
+        </p:txBody>
+      </p:sp>
+      <p:sp>
+        <p:nvSpPr>
+          <p:cNvPr id="5" name="source-attribution"/>
+          <p:cNvSpPr/>
+          <p:nvPr/>
+        </p:nvSpPr>
+        <p:spPr>
+          <a:xfrm>
+            <a:off x="457200" y="6446520"/>
+            <a:ext cx="11247120" cy="274320"/>
+          </a:xfrm>
+          <a:prstGeom prst="rect">
+            <a:avLst/>
+          </a:prstGeom>
+          <a:noFill/>
+          <a:ln/>
+        </p:spPr>
+        <p:txBody>
+          <a:bodyPr wrap="square" lIns="0" tIns="0" rIns="0" bIns="0" rtlCol="0" anchor="t"/>
+          <a:lstStyle/>
+          <a:p>
+            <a:pPr algn="l" indent="0" marL="0">
+              <a:buNone/>
+            </a:pPr>
+            <a:r>
+              <a:rPr lang="en-US" sz="800" dirty="0">
+                <a:solidFill>
+                  <a:srgbClr val="173248"/>
+                </a:solidFill>
+                <a:latin typeface="Noto Sans CJK SC" pitchFamily="34" charset="0"/>
+                <a:ea typeface="Noto Sans CJK SC" pitchFamily="34" charset="-122"/>
+                <a:cs typeface="Noto Sans CJK SC" pitchFamily="34" charset="-120"/>
+              </a:rPr>
+              <a:t>[basis] https://s2.q4cdn.com/470004039/files/doc_earnings/2024/q4/filing/10-Q4-2024-As-Filed.pdf ; local:data-dictionary.json · PDF 第 32 页／印刷第 29 页 ; asOf、currency、unit、basis；[audit] https://s2.q4cdn.com/470004039/files/doc_earnings/2024/q4/filing/10-Q4-2024-As-Filed.pdf · PDF 第 51 页／印刷第 48 页；[release-status] https://www.apple.com/newsroom/pdfs/fy2024-q4/FY24_Q4_Consolidated_Financial_Statements.pdf · PDF 第 1 页</a:t>
+            </a:r>
+            <a:endParaRPr lang="en-US" sz="800" dirty="0"/>
           </a:p>
         </p:txBody>
       </p:sp>
@@ -2460,7 +2551,7 @@
         </p:nvSpPr>
         <p:spPr>
           <a:xfrm>
-            <a:off x="822960" y="6355080"/>
+            <a:off x="822960" y="6053328"/>
             <a:ext cx="10424160" cy="228600"/>
           </a:xfrm>
           <a:prstGeom prst="rect">
@@ -2488,6 +2579,45 @@
               <a:t>来源：Apple FY2024 Form 10-K；待财务审阅</a:t>
             </a:r>
             <a:endParaRPr lang="en-US" sz="900" dirty="0"/>
+          </a:p>
+        </p:txBody>
+      </p:sp>
+      <p:sp>
+        <p:nvSpPr>
+          <p:cNvPr id="5" name="source-attribution"/>
+          <p:cNvSpPr/>
+          <p:nvPr/>
+        </p:nvSpPr>
+        <p:spPr>
+          <a:xfrm>
+            <a:off x="457200" y="6446520"/>
+            <a:ext cx="11247120" cy="274320"/>
+          </a:xfrm>
+          <a:prstGeom prst="rect">
+            <a:avLst/>
+          </a:prstGeom>
+          <a:noFill/>
+          <a:ln/>
+        </p:spPr>
+        <p:txBody>
+          <a:bodyPr wrap="square" lIns="0" tIns="0" rIns="0" bIns="0" rtlCol="0" anchor="t"/>
+          <a:lstStyle/>
+          <a:p>
+            <a:pPr algn="l" indent="0" marL="0">
+              <a:buNone/>
+            </a:pPr>
+            <a:r>
+              <a:rPr lang="en-US" sz="800" dirty="0">
+                <a:solidFill>
+                  <a:srgbClr val="173248"/>
+                </a:solidFill>
+                <a:latin typeface="Noto Sans CJK SC" pitchFamily="34" charset="0"/>
+                <a:ea typeface="Noto Sans CJK SC" pitchFamily="34" charset="-122"/>
+                <a:cs typeface="Noto Sans CJK SC" pitchFamily="34" charset="-120"/>
+              </a:rPr>
+              <a:t>[basis] https://s2.q4cdn.com/470004039/files/doc_earnings/2024/q4/filing/10-Q4-2024-As-Filed.pdf ; local:data-dictionary.json · PDF 第 32 页／印刷第 29 页 ; asOf、currency、unit、basis；[audit] https://s2.q4cdn.com/470004039/files/doc_earnings/2024/q4/filing/10-Q4-2024-As-Filed.pdf · PDF 第 51 页／印刷第 48 页；[release-status] https://www.apple.com/newsroom/pdfs/fy2024-q4/FY24_Q4_Consolidated_Financial_Statements.pdf · PDF 第 1 页</a:t>
+            </a:r>
+            <a:endParaRPr lang="en-US" sz="800" dirty="0"/>
           </a:p>
         </p:txBody>
       </p:sp>
@@ -2595,7 +2725,7 @@
                 <a:ea typeface="Noto Sans CJK SC" pitchFamily="34" charset="-122"/>
                 <a:cs typeface="Noto Sans CJK SC" pitchFamily="34" charset="-120"/>
               </a:rPr>
-              <a:t>2023：383,285；2024：391,035；同比 2.02%。审计年报第 29 页。</a:t>
+              <a:t>2023：383,285；2024：391,035；同比 +2.02%。审计年报第 29 页。</a:t>
             </a:r>
             <a:endParaRPr lang="en-US" sz="1800" dirty="0"/>
           </a:p>
@@ -2625,7 +2755,7 @@
         </p:nvSpPr>
         <p:spPr>
           <a:xfrm>
-            <a:off x="822960" y="6355080"/>
+            <a:off x="822960" y="6053328"/>
             <a:ext cx="10424160" cy="228600"/>
           </a:xfrm>
           <a:prstGeom prst="rect">
@@ -2674,10 +2804,10 @@
           <a:ln/>
         </p:spPr>
         <p:txBody>
-          <a:bodyPr wrap="square" lIns="0" tIns="0" rIns="0" bIns="0" rtlCol="0" anchor="ctr"/>
-          <a:lstStyle/>
-          <a:p>
-            <a:pPr indent="0" marL="0">
+          <a:bodyPr wrap="square" lIns="0" tIns="0" rIns="0" bIns="0" rtlCol="0" anchor="t"/>
+          <a:lstStyle/>
+          <a:p>
+            <a:pPr algn="l" indent="0" marL="0">
               <a:buNone/>
             </a:pPr>
             <a:r>
@@ -2689,7 +2819,7 @@
                 <a:ea typeface="Noto Sans CJK SC" pitchFamily="34" charset="-122"/>
                 <a:cs typeface="Noto Sans CJK SC" pitchFamily="34" charset="-120"/>
               </a:rPr>
-              <a:t>[net_sales] Apple Inc. FY2024 Form 10-K, audited consolidated statements · 印刷第 29 页</a:t>
+              <a:t>[net_sales-2023] https://s2.q4cdn.com/470004039/files/doc_earnings/2024/q4/filing/10-Q4-2024-As-Filed.pdf ; local:independent-recalc.csv · PDF 32 / 印 29 ; CSV net_sales FY2023；[net_sales-2024] https://s2.q4cdn.com/470004039/files/doc_earnings/2024/q4/filing/10-Q4-2024-As-Filed.pdf ; local:independent-recalc.csv · PDF 32 / 印 29 ; CSV net_sales FY2024；[net_sales-yoy] local:independent-recalc.csv · CSV net_sales 行</a:t>
             </a:r>
             <a:endParaRPr lang="en-US" sz="800" dirty="0"/>
           </a:p>
@@ -2829,7 +2959,7 @@
         </p:nvSpPr>
         <p:spPr>
           <a:xfrm>
-            <a:off x="822960" y="6355080"/>
+            <a:off x="822960" y="6053328"/>
             <a:ext cx="10424160" cy="228600"/>
           </a:xfrm>
           <a:prstGeom prst="rect">
@@ -2878,10 +3008,10 @@
           <a:ln/>
         </p:spPr>
         <p:txBody>
-          <a:bodyPr wrap="square" lIns="0" tIns="0" rIns="0" bIns="0" rtlCol="0" anchor="ctr"/>
-          <a:lstStyle/>
-          <a:p>
-            <a:pPr indent="0" marL="0">
+          <a:bodyPr wrap="square" lIns="0" tIns="0" rIns="0" bIns="0" rtlCol="0" anchor="t"/>
+          <a:lstStyle/>
+          <a:p>
+            <a:pPr algn="l" indent="0" marL="0">
               <a:buNone/>
             </a:pPr>
             <a:r>
@@ -2893,7 +3023,7 @@
                 <a:ea typeface="Noto Sans CJK SC" pitchFamily="34" charset="-122"/>
                 <a:cs typeface="Noto Sans CJK SC" pitchFamily="34" charset="-120"/>
               </a:rPr>
-              <a:t>[net_income] Apple Inc. FY2024 Form 10-K, audited consolidated statements · 印刷第 29 页</a:t>
+              <a:t>[net_income-2023] https://s2.q4cdn.com/470004039/files/doc_earnings/2024/q4/filing/10-Q4-2024-As-Filed.pdf ; local:independent-recalc.csv · PDF 32 / 印 29 ; CSV net_income FY2023；[net_income-2024] https://s2.q4cdn.com/470004039/files/doc_earnings/2024/q4/filing/10-Q4-2024-As-Filed.pdf ; local:independent-recalc.csv · PDF 32 / 印 29 ; CSV net_income FY2024；[net_income-yoy] local:independent-recalc.csv · CSV net_income 行</a:t>
             </a:r>
             <a:endParaRPr lang="en-US" sz="800" dirty="0"/>
           </a:p>
@@ -3033,7 +3163,7 @@
         </p:nvSpPr>
         <p:spPr>
           <a:xfrm>
-            <a:off x="822960" y="6355080"/>
+            <a:off x="822960" y="6053328"/>
             <a:ext cx="10424160" cy="228600"/>
           </a:xfrm>
           <a:prstGeom prst="rect">
@@ -3082,10 +3212,10 @@
           <a:ln/>
         </p:spPr>
         <p:txBody>
-          <a:bodyPr wrap="square" lIns="0" tIns="0" rIns="0" bIns="0" rtlCol="0" anchor="ctr"/>
-          <a:lstStyle/>
-          <a:p>
-            <a:pPr indent="0" marL="0">
+          <a:bodyPr wrap="square" lIns="0" tIns="0" rIns="0" bIns="0" rtlCol="0" anchor="t"/>
+          <a:lstStyle/>
+          <a:p>
+            <a:pPr algn="l" indent="0" marL="0">
               <a:buNone/>
             </a:pPr>
             <a:r>
@@ -3097,7 +3227,7 @@
                 <a:ea typeface="Noto Sans CJK SC" pitchFamily="34" charset="-122"/>
                 <a:cs typeface="Noto Sans CJK SC" pitchFamily="34" charset="-120"/>
               </a:rPr>
-              <a:t>[operating_cash_flow] Apple Inc. FY2024 Form 10-K, audited consolidated statements · 印刷第 33 页</a:t>
+              <a:t>[operating_cash_flow-2023] https://s2.q4cdn.com/470004039/files/doc_earnings/2024/q4/filing/10-Q4-2024-As-Filed.pdf ; local:independent-recalc.csv · PDF 36 / 印 33 ; CSV operating_cash_flow FY2023；[operating_cash_flow-2024] https://s2.q4cdn.com/470004039/files/doc_earnings/2024/q4/filing/10-Q4-2024-As-Filed.pdf ; local:independent-recalc.csv · PDF 36 / 印 33 ; CSV operating_cash_flow FY2024；[operating_cash_flow-yoy] local:independent-recalc.csv · CSV operating_cash_flow 行</a:t>
             </a:r>
             <a:endParaRPr lang="en-US" sz="800" dirty="0"/>
           </a:p>
@@ -3221,7 +3351,7 @@
         </p:nvSpPr>
         <p:spPr>
           <a:xfrm>
-            <a:off x="822960" y="6355080"/>
+            <a:off x="822960" y="6053328"/>
             <a:ext cx="10424160" cy="228600"/>
           </a:xfrm>
           <a:prstGeom prst="rect">
@@ -3249,6 +3379,45 @@
               <a:t>来源：Apple FY2024 Form 10-K；待财务审阅</a:t>
             </a:r>
             <a:endParaRPr lang="en-US" sz="900" dirty="0"/>
+          </a:p>
+        </p:txBody>
+      </p:sp>
+      <p:sp>
+        <p:nvSpPr>
+          <p:cNvPr id="5" name="source-attribution"/>
+          <p:cNvSpPr/>
+          <p:nvPr/>
+        </p:nvSpPr>
+        <p:spPr>
+          <a:xfrm>
+            <a:off x="457200" y="6446520"/>
+            <a:ext cx="11247120" cy="274320"/>
+          </a:xfrm>
+          <a:prstGeom prst="rect">
+            <a:avLst/>
+          </a:prstGeom>
+          <a:noFill/>
+          <a:ln/>
+        </p:spPr>
+        <p:txBody>
+          <a:bodyPr wrap="square" lIns="0" tIns="0" rIns="0" bIns="0" rtlCol="0" anchor="t"/>
+          <a:lstStyle/>
+          <a:p>
+            <a:pPr algn="l" indent="0" marL="0">
+              <a:buNone/>
+            </a:pPr>
+            <a:r>
+              <a:rPr lang="en-US" sz="800" dirty="0">
+                <a:solidFill>
+                  <a:srgbClr val="173248"/>
+                </a:solidFill>
+                <a:latin typeface="Noto Sans CJK SC" pitchFamily="34" charset="0"/>
+                <a:ea typeface="Noto Sans CJK SC" pitchFamily="34" charset="-122"/>
+                <a:cs typeface="Noto Sans CJK SC" pitchFamily="34" charset="-120"/>
+              </a:rPr>
+              <a:t>[net_sales-yoy] local:independent-recalc.csv · CSV net_sales 行；[net_income-yoy] local:independent-recalc.csv · CSV net_income 行；[operating_cash_flow-yoy] local:independent-recalc.csv · CSV operating_cash_flow 行</a:t>
+            </a:r>
+            <a:endParaRPr lang="en-US" sz="800" dirty="0"/>
           </a:p>
         </p:txBody>
       </p:sp>
@@ -3370,7 +3539,7 @@
         </p:nvSpPr>
         <p:spPr>
           <a:xfrm>
-            <a:off x="822960" y="6355080"/>
+            <a:off x="822960" y="6053328"/>
             <a:ext cx="10424160" cy="228600"/>
           </a:xfrm>
           <a:prstGeom prst="rect">
@@ -3398,6 +3567,45 @@
               <a:t>来源：Apple FY2024 Form 10-K；待财务审阅</a:t>
             </a:r>
             <a:endParaRPr lang="en-US" sz="900" dirty="0"/>
+          </a:p>
+        </p:txBody>
+      </p:sp>
+      <p:sp>
+        <p:nvSpPr>
+          <p:cNvPr id="5" name="source-attribution"/>
+          <p:cNvSpPr/>
+          <p:nvPr/>
+        </p:nvSpPr>
+        <p:spPr>
+          <a:xfrm>
+            <a:off x="457200" y="6446520"/>
+            <a:ext cx="11247120" cy="274320"/>
+          </a:xfrm>
+          <a:prstGeom prst="rect">
+            <a:avLst/>
+          </a:prstGeom>
+          <a:noFill/>
+          <a:ln/>
+        </p:spPr>
+        <p:txBody>
+          <a:bodyPr wrap="square" lIns="0" tIns="0" rIns="0" bIns="0" rtlCol="0" anchor="t"/>
+          <a:lstStyle/>
+          <a:p>
+            <a:pPr algn="l" indent="0" marL="0">
+              <a:buNone/>
+            </a:pPr>
+            <a:r>
+              <a:rPr lang="en-US" sz="800" dirty="0">
+                <a:solidFill>
+                  <a:srgbClr val="173248"/>
+                </a:solidFill>
+                <a:latin typeface="Noto Sans CJK SC" pitchFamily="34" charset="0"/>
+                <a:ea typeface="Noto Sans CJK SC" pitchFamily="34" charset="-122"/>
+                <a:cs typeface="Noto Sans CJK SC" pitchFamily="34" charset="-120"/>
+              </a:rPr>
+              <a:t>[net_income-yoy] local:independent-recalc.csv · CSV net_income 行；[release-status] https://www.apple.com/newsroom/pdfs/fy2024-q4/FY24_Q4_Consolidated_Financial_Statements.pdf · PDF 第 1 页</a:t>
+            </a:r>
+            <a:endParaRPr lang="en-US" sz="800" dirty="0"/>
           </a:p>
         </p:txBody>
       </p:sp>
@@ -3519,7 +3727,7 @@
         </p:nvSpPr>
         <p:spPr>
           <a:xfrm>
-            <a:off x="822960" y="6355080"/>
+            <a:off x="822960" y="6053328"/>
             <a:ext cx="10424160" cy="228600"/>
           </a:xfrm>
           <a:prstGeom prst="rect">
@@ -3547,6 +3755,45 @@
               <a:t>来源：Apple FY2024 Form 10-K；待财务审阅</a:t>
             </a:r>
             <a:endParaRPr lang="en-US" sz="900" dirty="0"/>
+          </a:p>
+        </p:txBody>
+      </p:sp>
+      <p:sp>
+        <p:nvSpPr>
+          <p:cNvPr id="5" name="source-attribution"/>
+          <p:cNvSpPr/>
+          <p:nvPr/>
+        </p:nvSpPr>
+        <p:spPr>
+          <a:xfrm>
+            <a:off x="457200" y="6446520"/>
+            <a:ext cx="11247120" cy="274320"/>
+          </a:xfrm>
+          <a:prstGeom prst="rect">
+            <a:avLst/>
+          </a:prstGeom>
+          <a:noFill/>
+          <a:ln/>
+        </p:spPr>
+        <p:txBody>
+          <a:bodyPr wrap="square" lIns="0" tIns="0" rIns="0" bIns="0" rtlCol="0" anchor="t"/>
+          <a:lstStyle/>
+          <a:p>
+            <a:pPr algn="l" indent="0" marL="0">
+              <a:buNone/>
+            </a:pPr>
+            <a:r>
+              <a:rPr lang="en-US" sz="800" dirty="0">
+                <a:solidFill>
+                  <a:srgbClr val="173248"/>
+                </a:solidFill>
+                <a:latin typeface="Noto Sans CJK SC" pitchFamily="34" charset="0"/>
+                <a:ea typeface="Noto Sans CJK SC" pitchFamily="34" charset="-122"/>
+                <a:cs typeface="Noto Sans CJK SC" pitchFamily="34" charset="-120"/>
+              </a:rPr>
+              <a:t>[basis] https://s2.q4cdn.com/470004039/files/doc_earnings/2024/q4/filing/10-Q4-2024-As-Filed.pdf ; local:data-dictionary.json · PDF 第 32 页／印刷第 29 页 ; asOf、currency、unit、basis；[audit] https://s2.q4cdn.com/470004039/files/doc_earnings/2024/q4/filing/10-Q4-2024-As-Filed.pdf · PDF 第 51 页／印刷第 48 页；[release-status] https://www.apple.com/newsroom/pdfs/fy2024-q4/FY24_Q4_Consolidated_Financial_Statements.pdf · PDF 第 1 页</a:t>
+            </a:r>
+            <a:endParaRPr lang="en-US" sz="800" dirty="0"/>
           </a:p>
         </p:txBody>
       </p:sp>

</xml_diff>